<commit_message>
fix(apresentacao): corrige bugs encontrados ao renderizar o deck
Renderizado com Chrome headless slide a slide. Correcoes:

- lista de destaques quebrava uma palavra por linha (span vazio ocupava a
  coluna do texto no grid do li), estourando a altura do slide e
  desalinhando o scroll-snap dos slides seguintes
- barra de progresso movida para a base: no topo colidia com a faixa de
  categoria e o mix-blend gerava cor espuria
- rodape passava por baixo dos botoes de navegacao
- capa ganhou o indice das categorias, alinhando HTML e PPTX
- diagrama de arquitetura refeito: os rotulos das setas cobriam as caixas,
  tanto no SVG quanto no PPTX

Co-Authored-By: Claude Opus 5 (1M context) <noreply@anthropic.com>
</commit_message>
<xml_diff>
--- a/apresentacao/pli-hub-apresentacao.pptx
+++ b/apresentacao/pli-hub-apresentacao.pptx
@@ -10601,7 +10601,7 @@
         <p:spPr>
           <a:xfrm>
             <a:off x="658368" y="2148840"/>
-            <a:ext cx="3200400" cy="201168"/>
+            <a:ext cx="2743200" cy="201168"/>
           </a:xfrm>
           <a:prstGeom prst="rect">
             <a:avLst/>
@@ -10640,7 +10640,7 @@
         <p:spPr>
           <a:xfrm>
             <a:off x="658368" y="2377440"/>
-            <a:ext cx="3200400" cy="914400"/>
+            <a:ext cx="2743200" cy="914400"/>
           </a:xfrm>
           <a:prstGeom prst="rect">
             <a:avLst/>
@@ -10730,7 +10730,7 @@
         <p:spPr>
           <a:xfrm>
             <a:off x="877824" y="2560320"/>
-            <a:ext cx="2788920" cy="274320"/>
+            <a:ext cx="2331720" cy="274320"/>
           </a:xfrm>
           <a:prstGeom prst="rect">
             <a:avLst/>
@@ -10769,7 +10769,7 @@
         <p:spPr>
           <a:xfrm>
             <a:off x="877824" y="2880360"/>
-            <a:ext cx="2788920" cy="320040"/>
+            <a:ext cx="2331720" cy="320040"/>
           </a:xfrm>
           <a:prstGeom prst="rect">
             <a:avLst/>
@@ -10808,7 +10808,7 @@
         <p:spPr>
           <a:xfrm>
             <a:off x="658368" y="3520440"/>
-            <a:ext cx="3200400" cy="914400"/>
+            <a:ext cx="2743200" cy="914400"/>
           </a:xfrm>
           <a:prstGeom prst="rect">
             <a:avLst/>
@@ -10898,7 +10898,7 @@
         <p:spPr>
           <a:xfrm>
             <a:off x="877824" y="3703320"/>
-            <a:ext cx="2788920" cy="274320"/>
+            <a:ext cx="2331720" cy="274320"/>
           </a:xfrm>
           <a:prstGeom prst="rect">
             <a:avLst/>
@@ -10937,7 +10937,7 @@
         <p:spPr>
           <a:xfrm>
             <a:off x="877824" y="4023360"/>
-            <a:ext cx="2788920" cy="320040"/>
+            <a:ext cx="2331720" cy="320040"/>
           </a:xfrm>
           <a:prstGeom prst="rect">
             <a:avLst/>
@@ -10976,7 +10976,7 @@
         <p:spPr>
           <a:xfrm>
             <a:off x="4590288" y="2148840"/>
-            <a:ext cx="3200400" cy="201168"/>
+            <a:ext cx="2743200" cy="201168"/>
           </a:xfrm>
           <a:prstGeom prst="rect">
             <a:avLst/>
@@ -11015,7 +11015,7 @@
         <p:spPr>
           <a:xfrm>
             <a:off x="4590288" y="2926080"/>
-            <a:ext cx="3200400" cy="914400"/>
+            <a:ext cx="2743200" cy="914400"/>
           </a:xfrm>
           <a:prstGeom prst="rect">
             <a:avLst/>
@@ -11105,7 +11105,7 @@
         <p:spPr>
           <a:xfrm>
             <a:off x="4809744" y="3108960"/>
-            <a:ext cx="2788920" cy="274320"/>
+            <a:ext cx="2331720" cy="274320"/>
           </a:xfrm>
           <a:prstGeom prst="rect">
             <a:avLst/>
@@ -11144,7 +11144,7 @@
         <p:spPr>
           <a:xfrm>
             <a:off x="4809744" y="3429000"/>
-            <a:ext cx="2788920" cy="320040"/>
+            <a:ext cx="2331720" cy="320040"/>
           </a:xfrm>
           <a:prstGeom prst="rect">
             <a:avLst/>
@@ -11182,8 +11182,8 @@
         </p:nvCxnSpPr>
         <p:spPr>
           <a:xfrm>
-            <a:off x="3858768" y="2834640"/>
-            <a:ext cx="731520" cy="365760"/>
+            <a:off x="3401568" y="2834640"/>
+            <a:ext cx="1188720" cy="365760"/>
           </a:xfrm>
           <a:prstGeom prst="line">
             <a:avLst/>
@@ -11217,8 +11217,8 @@
         </p:nvSpPr>
         <p:spPr>
           <a:xfrm>
-            <a:off x="3218688" y="2724912"/>
-            <a:ext cx="2011680" cy="219456"/>
+            <a:off x="3429000" y="2706624"/>
+            <a:ext cx="1133856" cy="219456"/>
           </a:xfrm>
           <a:prstGeom prst="rect">
             <a:avLst/>
@@ -11237,7 +11237,7 @@
               </a:lnSpc>
             </a:pPr>
             <a:r>
-              <a:rPr sz="800" b="0">
+              <a:rPr sz="750" b="0">
                 <a:solidFill>
                   <a:srgbClr val="5D8296"/>
                 </a:solidFill>
@@ -11256,8 +11256,8 @@
         </p:nvCxnSpPr>
         <p:spPr>
           <a:xfrm flipV="1">
-            <a:off x="3858768" y="3611880"/>
-            <a:ext cx="731520" cy="365759"/>
+            <a:off x="3401568" y="3611880"/>
+            <a:ext cx="1188720" cy="365759"/>
           </a:xfrm>
           <a:prstGeom prst="line">
             <a:avLst/>
@@ -11291,8 +11291,8 @@
         </p:nvSpPr>
         <p:spPr>
           <a:xfrm>
-            <a:off x="3218688" y="3502151"/>
-            <a:ext cx="2011680" cy="219456"/>
+            <a:off x="3429000" y="3483863"/>
+            <a:ext cx="1133856" cy="219456"/>
           </a:xfrm>
           <a:prstGeom prst="rect">
             <a:avLst/>
@@ -11311,7 +11311,7 @@
               </a:lnSpc>
             </a:pPr>
             <a:r>
-              <a:rPr sz="800" b="0">
+              <a:rPr sz="750" b="0">
                 <a:solidFill>
                   <a:srgbClr val="5D8296"/>
                 </a:solidFill>
@@ -11331,7 +11331,7 @@
         <p:spPr>
           <a:xfrm>
             <a:off x="8522208" y="2148840"/>
-            <a:ext cx="3200400" cy="201168"/>
+            <a:ext cx="2743200" cy="201168"/>
           </a:xfrm>
           <a:prstGeom prst="rect">
             <a:avLst/>
@@ -11370,7 +11370,7 @@
         <p:spPr>
           <a:xfrm>
             <a:off x="8522208" y="2377440"/>
-            <a:ext cx="3200400" cy="914400"/>
+            <a:ext cx="2743200" cy="914400"/>
           </a:xfrm>
           <a:prstGeom prst="rect">
             <a:avLst/>
@@ -11460,7 +11460,7 @@
         <p:spPr>
           <a:xfrm>
             <a:off x="8741664" y="2560320"/>
-            <a:ext cx="2788920" cy="274320"/>
+            <a:ext cx="2331720" cy="274320"/>
           </a:xfrm>
           <a:prstGeom prst="rect">
             <a:avLst/>
@@ -11499,7 +11499,7 @@
         <p:spPr>
           <a:xfrm>
             <a:off x="8741664" y="2880360"/>
-            <a:ext cx="2788920" cy="320040"/>
+            <a:ext cx="2331720" cy="320040"/>
           </a:xfrm>
           <a:prstGeom prst="rect">
             <a:avLst/>
@@ -11538,7 +11538,7 @@
         <p:spPr>
           <a:xfrm>
             <a:off x="8522208" y="3520440"/>
-            <a:ext cx="3200400" cy="914400"/>
+            <a:ext cx="2743200" cy="914400"/>
           </a:xfrm>
           <a:prstGeom prst="rect">
             <a:avLst/>
@@ -11628,7 +11628,7 @@
         <p:spPr>
           <a:xfrm>
             <a:off x="8741664" y="3703320"/>
-            <a:ext cx="2788920" cy="274320"/>
+            <a:ext cx="2331720" cy="274320"/>
           </a:xfrm>
           <a:prstGeom prst="rect">
             <a:avLst/>
@@ -11667,7 +11667,7 @@
         <p:spPr>
           <a:xfrm>
             <a:off x="8741664" y="4023360"/>
-            <a:ext cx="2788920" cy="320040"/>
+            <a:ext cx="2331720" cy="320040"/>
           </a:xfrm>
           <a:prstGeom prst="rect">
             <a:avLst/>
@@ -11706,7 +11706,7 @@
         <p:spPr>
           <a:xfrm>
             <a:off x="658368" y="4937760"/>
-            <a:ext cx="3200400" cy="201168"/>
+            <a:ext cx="2743200" cy="201168"/>
           </a:xfrm>
           <a:prstGeom prst="rect">
             <a:avLst/>
@@ -11745,7 +11745,7 @@
         <p:spPr>
           <a:xfrm>
             <a:off x="658368" y="5166360"/>
-            <a:ext cx="3200400" cy="914400"/>
+            <a:ext cx="2743200" cy="914400"/>
           </a:xfrm>
           <a:prstGeom prst="rect">
             <a:avLst/>
@@ -11835,7 +11835,7 @@
         <p:spPr>
           <a:xfrm>
             <a:off x="877824" y="5349240"/>
-            <a:ext cx="2788920" cy="274320"/>
+            <a:ext cx="2331720" cy="274320"/>
           </a:xfrm>
           <a:prstGeom prst="rect">
             <a:avLst/>
@@ -11874,7 +11874,7 @@
         <p:spPr>
           <a:xfrm>
             <a:off x="877824" y="5669280"/>
-            <a:ext cx="2788920" cy="320040"/>
+            <a:ext cx="2331720" cy="320040"/>
           </a:xfrm>
           <a:prstGeom prst="rect">
             <a:avLst/>
@@ -11913,7 +11913,7 @@
         <p:spPr>
           <a:xfrm>
             <a:off x="4590288" y="4937760"/>
-            <a:ext cx="3200400" cy="201168"/>
+            <a:ext cx="2743200" cy="201168"/>
           </a:xfrm>
           <a:prstGeom prst="rect">
             <a:avLst/>
@@ -11952,7 +11952,7 @@
         <p:spPr>
           <a:xfrm>
             <a:off x="4590288" y="5166360"/>
-            <a:ext cx="3200400" cy="914400"/>
+            <a:ext cx="2743200" cy="914400"/>
           </a:xfrm>
           <a:prstGeom prst="rect">
             <a:avLst/>
@@ -12042,7 +12042,7 @@
         <p:spPr>
           <a:xfrm>
             <a:off x="4809744" y="5349240"/>
-            <a:ext cx="2788920" cy="274320"/>
+            <a:ext cx="2331720" cy="274320"/>
           </a:xfrm>
           <a:prstGeom prst="rect">
             <a:avLst/>
@@ -12081,7 +12081,7 @@
         <p:spPr>
           <a:xfrm>
             <a:off x="4809744" y="5669280"/>
-            <a:ext cx="2788920" cy="320040"/>
+            <a:ext cx="2331720" cy="320040"/>
           </a:xfrm>
           <a:prstGeom prst="rect">
             <a:avLst/>
@@ -12120,7 +12120,7 @@
         <p:spPr>
           <a:xfrm>
             <a:off x="8522208" y="4937760"/>
-            <a:ext cx="3200400" cy="201168"/>
+            <a:ext cx="2743200" cy="201168"/>
           </a:xfrm>
           <a:prstGeom prst="rect">
             <a:avLst/>
@@ -12159,7 +12159,7 @@
         <p:spPr>
           <a:xfrm>
             <a:off x="8522208" y="5166360"/>
-            <a:ext cx="3200400" cy="914400"/>
+            <a:ext cx="2743200" cy="914400"/>
           </a:xfrm>
           <a:prstGeom prst="rect">
             <a:avLst/>
@@ -12249,7 +12249,7 @@
         <p:spPr>
           <a:xfrm>
             <a:off x="8741664" y="5349240"/>
-            <a:ext cx="2788920" cy="274320"/>
+            <a:ext cx="2331720" cy="274320"/>
           </a:xfrm>
           <a:prstGeom prst="rect">
             <a:avLst/>
@@ -12288,7 +12288,7 @@
         <p:spPr>
           <a:xfrm>
             <a:off x="8741664" y="5669280"/>
-            <a:ext cx="2788920" cy="320040"/>
+            <a:ext cx="2331720" cy="320040"/>
           </a:xfrm>
           <a:prstGeom prst="rect">
             <a:avLst/>
@@ -12326,8 +12326,8 @@
         </p:nvCxnSpPr>
         <p:spPr>
           <a:xfrm>
-            <a:off x="3858768" y="5623560"/>
-            <a:ext cx="731520" cy="0"/>
+            <a:off x="3401568" y="5623560"/>
+            <a:ext cx="1188720" cy="0"/>
           </a:xfrm>
           <a:prstGeom prst="line">
             <a:avLst/>
@@ -12361,8 +12361,8 @@
         </p:nvSpPr>
         <p:spPr>
           <a:xfrm>
-            <a:off x="3218688" y="5330952"/>
-            <a:ext cx="2011680" cy="219456"/>
+            <a:off x="3429000" y="5312664"/>
+            <a:ext cx="1133856" cy="219456"/>
           </a:xfrm>
           <a:prstGeom prst="rect">
             <a:avLst/>
@@ -12381,13 +12381,13 @@
               </a:lnSpc>
             </a:pPr>
             <a:r>
-              <a:rPr sz="800" b="0">
+              <a:rPr sz="750" b="0">
                 <a:solidFill>
                   <a:srgbClr val="5D8296"/>
                 </a:solidFill>
                 <a:latin typeface="Consolas"/>
               </a:rPr>
-              <a:t>AUTENTICAÇÃO E CADASTROS</a:t>
+              <a:t>LOGIN E CADASTROS</a:t>
             </a:r>
           </a:p>
         </p:txBody>
@@ -12400,8 +12400,8 @@
         </p:nvCxnSpPr>
         <p:spPr>
           <a:xfrm flipH="1">
-            <a:off x="7790688" y="5623560"/>
-            <a:ext cx="731520" cy="0"/>
+            <a:off x="7333488" y="5623560"/>
+            <a:ext cx="1188720" cy="0"/>
           </a:xfrm>
           <a:prstGeom prst="line">
             <a:avLst/>
@@ -12435,8 +12435,8 @@
         </p:nvSpPr>
         <p:spPr>
           <a:xfrm>
-            <a:off x="7150608" y="5330952"/>
-            <a:ext cx="2011680" cy="219456"/>
+            <a:off x="7360920" y="5312664"/>
+            <a:ext cx="1133856" cy="219456"/>
           </a:xfrm>
           <a:prstGeom prst="rect">
             <a:avLst/>
@@ -12455,13 +12455,13 @@
               </a:lnSpc>
             </a:pPr>
             <a:r>
-              <a:rPr sz="800" b="0">
+              <a:rPr sz="750" b="0">
                 <a:solidFill>
                   <a:srgbClr val="5D8296"/>
                 </a:solidFill>
                 <a:latin typeface="Consolas"/>
               </a:rPr>
-              <a:t>MÉTODO MULTICRITÉRIO</a:t>
+              <a:t>MÉTODO AHP</a:t>
             </a:r>
           </a:p>
         </p:txBody>

</xml_diff>